<commit_message>
Update PPT with correct section (2CSE3)
</commit_message>
<xml_diff>
--- a/Internship_PPT.pptx
+++ b/Internship_PPT.pptx
@@ -2329,7 +2329,7 @@
                 <a:ea typeface="Calibri" pitchFamily="34" charset="-122"/>
                 <a:cs typeface="Calibri" pitchFamily="34" charset="-120"/>
               </a:rPr>
-              <a:t>Roll No. 25SCS1003003064   ·   Section 1CSE25   ·   3rd Semester   ·   Session 2025-29</a:t>
+              <a:t>Roll No. 25SCS1003003064   ·   Section 2CSE3   ·   3rd Semester   ·   Session 2025-29</a:t>
             </a:r>
             <a:endParaRPr lang="en-US" sz="1200" dirty="0"/>
           </a:p>
@@ -6011,7 +6011,7 @@
                 <a:ea typeface="Calibri" pitchFamily="34" charset="-122"/>
                 <a:cs typeface="Calibri" pitchFamily="34" charset="-120"/>
               </a:rPr>
-              <a:t>Samvit Srivastava   ·   Roll No. 25SCS1003003064   ·   Section 1CSE25   ·   3rd Semester</a:t>
+              <a:t>Samvit Srivastava   ·   Roll No. 25SCS1003003064   ·   Section 2CSE3   ·   3rd Semester</a:t>
             </a:r>
             <a:endParaRPr lang="en-US" sz="1300" dirty="0"/>
           </a:p>

</xml_diff>